<commit_message>
EC2: la URL cambia en cada sesión de AWS Academy
</commit_message>
<xml_diff>
--- a/presentacion/Musicfy-Presentacion.pptx
+++ b/presentacion/Musicfy-Presentacion.pptx
@@ -130,12 +130,12 @@
   <p:extLst>
     <p:ext uri="{521415D9-36F7-43E2-AB2F-B90AF26B5E84}">
       <p14:sectionLst xmlns:p14="http://schemas.microsoft.com/office/powerpoint/2010/main">
-        <p14:section name="Portada" id="{59831465-608b-b004-836e-fdb661c54a88}">
+        <p14:section name="Portada" id="{cff7738f-e680-5e94-d8e0-a0f0d790dc7c}">
           <p14:sldIdLst>
             <p14:sldId id="256"/>
           </p14:sldIdLst>
         </p14:section>
-        <p14:section name="Proyecto" id="{14321caa-3285-1e8e-4869-7b72a8195910}">
+        <p14:section name="Proyecto" id="{d2125d33-9f8e-ef87-29e9-e77c66523e32}">
           <p14:sldIdLst>
             <p14:sldId id="257"/>
             <p14:sldId id="258"/>
@@ -143,35 +143,35 @@
             <p14:sldId id="260"/>
           </p14:sldIdLst>
         </p14:section>
-        <p14:section name="ERS" id="{2e858e48-d297-ba39-772f-9e1418a6944d}">
+        <p14:section name="ERS" id="{a2146a42-17ed-8fac-d93b-1163a96a8d5e}">
           <p14:sldIdLst>
             <p14:sldId id="261"/>
             <p14:sldId id="262"/>
             <p14:sldId id="263"/>
           </p14:sldIdLst>
         </p14:section>
-        <p14:section name="Diagramas" id="{dc95ad4a-64ca-ded9-d8d2-b1d41d3bff9f}">
+        <p14:section name="Diagramas" id="{a49161f7-cc1b-048f-d6b0-bbccf0624cfd}">
           <p14:sldIdLst>
             <p14:sldId id="264"/>
             <p14:sldId id="265"/>
             <p14:sldId id="266"/>
           </p14:sldIdLst>
         </p14:section>
-        <p14:section name="App 1" id="{03c31139-39ad-d969-f6c4-72dfc1e5d8e0}">
+        <p14:section name="App 1" id="{d82b21f4-999a-7ac9-e672-59a527fee9e9}">
           <p14:sldIdLst>
             <p14:sldId id="267"/>
             <p14:sldId id="268"/>
             <p14:sldId id="269"/>
           </p14:sldIdLst>
         </p14:section>
-        <p14:section name="App 2" id="{5939cf77-6bcb-df43-0cf4-fcc4acd67318}">
+        <p14:section name="App 2" id="{5e04a9f2-5163-22b2-d6d5-a8864380181f}">
           <p14:sldIdLst>
             <p14:sldId id="270"/>
             <p14:sldId id="271"/>
             <p14:sldId id="272"/>
           </p14:sldIdLst>
         </p14:section>
-        <p14:section name="Calidad y despliegue" id="{12f79a80-cf9f-669e-2c76-5658280083a9}">
+        <p14:section name="Calidad y despliegue" id="{d8dd7efc-7481-75d1-bcad-2fe8314a7571}">
           <p14:sldIdLst>
             <p14:sldId id="273"/>
             <p14:sldId id="274"/>
@@ -179,7 +179,7 @@
             <p14:sldId id="276"/>
           </p14:sldIdLst>
         </p14:section>
-        <p14:section name="Cierre" id="{5f6dc073-0e21-dfcf-30f2-9f63348346a2}">
+        <p14:section name="Cierre" id="{8a9798d1-12fb-ff67-83a2-004a31d86b9d}">
           <p14:sldIdLst>
             <p14:sldId id="277"/>
             <p14:sldId id="278"/>
@@ -15594,7 +15594,7 @@
       </p:sp>
       <p:sp>
         <p:nvSpPr>
-          <p:cNvPr id="16" name="cambiar555"/>
+          <p:cNvPr id="16" name="card555"/>
           <p:cNvSpPr/>
           <p:nvPr/>
         </p:nvSpPr>
@@ -15609,9 +15609,14 @@
             </a:avLst>
           </a:prstGeom>
           <a:solidFill>
-            <a:schemeClr val="accent4"/>
+            <a:schemeClr val="tx2"/>
           </a:solidFill>
-          <a:ln/>
+          <a:ln w="9525">
+            <a:solidFill>
+              <a:schemeClr val="accent6"/>
+            </a:solidFill>
+            <a:prstDash val="solid"/>
+          </a:ln>
         </p:spPr>
       </p:sp>
       <p:sp>
@@ -15622,8 +15627,8 @@
         </p:nvSpPr>
         <p:spPr>
           <a:xfrm>
-            <a:off x="685800" y="5669280"/>
-            <a:ext cx="10835640" cy="384048"/>
+            <a:off x="731520" y="5669280"/>
+            <a:ext cx="10789920" cy="384048"/>
           </a:xfrm>
           <a:prstGeom prst="rect">
             <a:avLst/>
@@ -15641,10 +15646,10 @@
             <a:r>
               <a:rPr lang="en-US" sz="1200" b="1" dirty="0">
                 <a:solidFill>
-                  <a:schemeClr val="tx1"/>
-                </a:solidFill>
-              </a:rPr>
-              <a:t>⚠ CAMBIAR  </a:t>
+                  <a:schemeClr val="accent6"/>
+                </a:solidFill>
+              </a:rPr>
+              <a:t>✓ Vercel CLI 65.5.0:  </a:t>
             </a:r>
             <a:pPr indent="0" marL="0">
               <a:buNone/>
@@ -15652,10 +15657,10 @@
             <a:r>
               <a:rPr lang="en-US" sz="1200" dirty="0">
                 <a:solidFill>
-                  <a:schemeClr val="tx1"/>
-                </a:solidFill>
-              </a:rPr>
-              <a:t>añadir evidencia de Vercel CLI (vercel --version, vercel deploy): el enunciado la pide.</a:t>
+                  <a:schemeClr val="bg1"/>
+                </a:solidFill>
+              </a:rPr>
+              <a:t>vercel link · vercel env ls (valores ocultos) · vercel ls (despliegues Ready)  →  docs/evidencias/vercel-cli.png</a:t>
             </a:r>
             <a:endParaRPr lang="en-US" sz="1200" dirty="0"/>
           </a:p>
@@ -17705,7 +17710,7 @@
                   <a:schemeClr val="accent3"/>
                 </a:solidFill>
               </a:rPr>
-              <a:t>EC2 · 32-200-106-42.sslip.io · docker compose</a:t>
+              <a:t>EC2 · &lt;IP&gt;.sslip.io · docker compose</a:t>
             </a:r>
             <a:endParaRPr lang="en-US" sz="1200" dirty="0"/>
           </a:p>
@@ -18417,7 +18422,7 @@
                   <a:schemeClr val="tx1"/>
                 </a:solidFill>
               </a:rPr>
-              <a:t>(Mario) región, tipo de instancia y captura de la demo con sesión iniciada. Comprobado el 28/10: HTTPS, /health 200 y 401 sin token.</a:t>
+              <a:t>(Mario) región y tipo de instancia. AWS Academy: 4 h por sesión y la IP cambia al relanzar → poner la URL del día. Probado 28/10: HTTPS, 200 y 401.</a:t>
             </a:r>
             <a:endParaRPr lang="en-US" sz="1200" dirty="0"/>
           </a:p>
@@ -22327,7 +22332,7 @@
                   <a:schemeClr val="bg1"/>
                 </a:solidFill>
               </a:rPr>
-              <a:t>App 2 en EC2 con HTTPS: 32-200-106-42.sslip.io.</a:t>
+              <a:t>App 2 en EC2 con HTTPS (o la grabación si la sesión de AWS ha caducado).</a:t>
             </a:r>
             <a:endParaRPr lang="en-US" sz="1400" dirty="0"/>
           </a:p>

</xml_diff>